<commit_message>
Professionalize nav labels site-wide: Events, Community, Approach, Testimonials, About
- Header nav + footer Explore links renamed (Gatherings->Events,
  Field Notes->Community, The Yatra Way->Approach, Kind Words->
  Testimonials, The Movement->About); footer gains missing Approach link
- Section eyebrows/headings aligned: new Events header, Community,
  Our approach, Testimonials, About AIYatra; body copy touch-ups
  (people behind AIYatra, AIYatra journey, one community)
- Deck generator v2 copy aligned + both .pptx regenerated and
  republished to public/decks
</commit_message>
<xml_diff>
--- a/apps/web/public/decks/AIYatra-Journey-From-Start-Till-Now.pptx
+++ b/apps/web/public/decks/AIYatra-Journey-From-Start-Till-Now.pptx
@@ -3317,7 +3317,7 @@
               </a:defRPr>
             </a:pPr>
             <a:r>
-              <a:t>Gatherings     Field Notes     The Yatra Way     Kind Words     Movement     Ambassadors     Blog</a:t>
+              <a:t>Events     Community     Approach     Testimonials     About     Ambassadors     Blog</a:t>
             </a:r>
           </a:p>
         </p:txBody>
@@ -5321,7 +5321,7 @@
               </a:defRPr>
             </a:pPr>
             <a:r>
-              <a:t>Gatherings     Field Notes     The Yatra Way     Kind Words     Movement     Ambassadors     Blog</a:t>
+              <a:t>Events     Community     Approach     Testimonials     About     Ambassadors     Blog</a:t>
             </a:r>
           </a:p>
         </p:txBody>
@@ -5485,7 +5485,7 @@
               </a:defRPr>
             </a:pPr>
             <a:r>
-              <a:t>●  GATHERINGS  ·  PAST SESSIONS</a:t>
+              <a:t>●  EVENTS  ·  PAST SESSIONS</a:t>
             </a:r>
           </a:p>
         </p:txBody>
@@ -7199,7 +7199,7 @@
               </a:defRPr>
             </a:pPr>
             <a:r>
-              <a:t>Gatherings     Field Notes     The Yatra Way     Kind Words     Movement     Ambassadors     Blog</a:t>
+              <a:t>Events     Community     Approach     Testimonials     About     Ambassadors     Blog</a:t>
             </a:r>
           </a:p>
         </p:txBody>
@@ -7363,7 +7363,7 @@
               </a:defRPr>
             </a:pPr>
             <a:r>
-              <a:t>◉  FIELD NOTES</a:t>
+              <a:t>◉  COMMUNITY</a:t>
             </a:r>
           </a:p>
         </p:txBody>
@@ -9043,7 +9043,7 @@
               </a:defRPr>
             </a:pPr>
             <a:r>
-              <a:t>Gatherings     Field Notes     The Yatra Way     Kind Words     Movement     Ambassadors     Blog</a:t>
+              <a:t>Events     Community     Approach     Testimonials     About     Ambassadors     Blog</a:t>
             </a:r>
           </a:p>
         </p:txBody>
@@ -9207,7 +9207,7 @@
               </a:defRPr>
             </a:pPr>
             <a:r>
-              <a:t>THE YATRA WAY</a:t>
+              <a:t>OUR APPROACH</a:t>
             </a:r>
           </a:p>
         </p:txBody>
@@ -10020,7 +10020,7 @@
               </a:defRPr>
             </a:pPr>
             <a:r>
-              <a:t>Skills become careers, side projects become products, and strangers become collaborators. That is the yatra — the journey.</a:t>
+              <a:t>Skills become careers, side projects become products, and strangers become collaborators. That is the AIYatra journey.</a:t>
             </a:r>
           </a:p>
         </p:txBody>
@@ -10458,7 +10458,7 @@
               </a:defRPr>
             </a:pPr>
             <a:r>
-              <a:t>Gatherings     Field Notes     The Yatra Way     Kind Words     Movement     Ambassadors     Blog</a:t>
+              <a:t>Events     Community     Approach     Testimonials     About     Ambassadors     Blog</a:t>
             </a:r>
           </a:p>
         </p:txBody>
@@ -10622,7 +10622,7 @@
               </a:defRPr>
             </a:pPr>
             <a:r>
-              <a:t>KIND WORDS</a:t>
+              <a:t>TESTIMONIALS</a:t>
             </a:r>
           </a:p>
         </p:txBody>
@@ -11896,7 +11896,7 @@
               </a:defRPr>
             </a:pPr>
             <a:r>
-              <a:t>Gatherings     Field Notes     The Yatra Way     Kind Words     Movement     Ambassadors     Blog</a:t>
+              <a:t>Events     Community     Approach     Testimonials     About     Ambassadors     Blog</a:t>
             </a:r>
           </a:p>
         </p:txBody>
@@ -12412,7 +12412,7 @@
               </a:defRPr>
             </a:pPr>
             <a:r>
-              <a:t>The people who run the yatra — Khaja Moinuddin Mohammed (Super Organizer) · Azeez Syed (Co-organizer &amp; Host) · Jagadeeswara Reddy (Host &amp; Educator)</a:t>
+              <a:t>The people behind AIYatra — Khaja Moinuddin Mohammed (Super Organizer) · Azeez Syed (Co-organizer &amp; Host) · Jagadeeswara Reddy (Host &amp; Educator)</a:t>
             </a:r>
           </a:p>
         </p:txBody>
@@ -12814,7 +12814,7 @@
               </a:defRPr>
             </a:pPr>
             <a:r>
-              <a:t>Gatherings     Field Notes     The Yatra Way     Kind Words     Movement     Ambassadors     Blog</a:t>
+              <a:t>Events     Community     Approach     Testimonials     About     Ambassadors     Blog</a:t>
             </a:r>
           </a:p>
         </p:txBody>
@@ -12978,7 +12978,7 @@
               </a:defRPr>
             </a:pPr>
             <a:r>
-              <a:t>THE MOVEMENT</a:t>
+              <a:t>ABOUT AIYATRA</a:t>
             </a:r>
           </a:p>
         </p:txBody>
@@ -14060,7 +14060,7 @@
               </a:defRPr>
             </a:pPr>
             <a:r>
-              <a:t>Gatherings     Field Notes     The Yatra Way     Kind Words     Movement     Ambassadors     Blog</a:t>
+              <a:t>Events     Community     Approach     Testimonials     About     Ambassadors     Blog</a:t>
             </a:r>
           </a:p>
         </p:txBody>
@@ -15044,7 +15044,7 @@
               </a:defRPr>
             </a:pPr>
             <a:r>
-              <a:t>Gatherings     Field Notes     The Yatra Way     Kind Words     Movement     Ambassadors     Blog</a:t>
+              <a:t>Events     Community     Approach     Testimonials     About     Ambassadors     Blog</a:t>
             </a:r>
           </a:p>
         </p:txBody>
@@ -15324,15 +15324,15 @@
             </a:r>
             <a:br/>
             <a:r>
-              <a:t>Gatherings</a:t>
+              <a:t>Events</a:t>
             </a:r>
             <a:br/>
             <a:r>
-              <a:t>Field Notes</a:t>
+              <a:t>Community</a:t>
             </a:r>
             <a:br/>
             <a:r>
-              <a:t>Kind Words</a:t>
+              <a:t>Testimonials</a:t>
             </a:r>
           </a:p>
         </p:txBody>

</xml_diff>